<commit_message>
Update docs and improve basket preparation button
Removed outdated meeting documents and added a new poster PDF. Updated the deployment target selector configuration for development. In BasketPreparationView, set the button color to GreenIPCA for better UI consistency.
</commit_message>
<xml_diff>
--- a/docs/poster.pptx
+++ b/docs/poster.pptx
@@ -3428,7 +3428,7 @@
         </p:blipFill>
         <p:spPr>
           <a:xfrm>
-            <a:off x="8060760" y="5116320"/>
+            <a:off x="11434500" y="5204160"/>
             <a:ext cx="304560" cy="367920"/>
           </a:xfrm>
           <a:prstGeom prst="rect">
@@ -3786,7 +3786,7 @@
         </p:nvSpPr>
         <p:spPr>
           <a:xfrm>
-            <a:off x="8408160" y="5028480"/>
+            <a:off x="11781900" y="5116320"/>
             <a:ext cx="4725720" cy="639360"/>
           </a:xfrm>
           <a:prstGeom prst="rect">
@@ -3825,7 +3825,7 @@
               </a:lnSpc>
             </a:pPr>
             <a:r>
-              <a:rPr lang="pt-PT" sz="3600" b="1" strike="noStrike" spc="-1">
+              <a:rPr lang="pt-PT" sz="3600" b="1" strike="noStrike" spc="-1" dirty="0">
                 <a:solidFill>
                   <a:srgbClr val="004B87"/>
                 </a:solidFill>
@@ -3833,7 +3833,7 @@
               </a:rPr>
               <a:t>OBJECTIVES</a:t>
             </a:r>
-            <a:endParaRPr lang="en-US" sz="3600" b="0" strike="noStrike" spc="-1">
+            <a:endParaRPr lang="en-US" sz="3600" b="0" strike="noStrike" spc="-1" dirty="0">
               <a:latin typeface="Arial"/>
             </a:endParaRPr>
           </a:p>
@@ -4073,8 +4073,8 @@
         </p:nvSpPr>
         <p:spPr>
           <a:xfrm>
-            <a:off x="7918200" y="5695560"/>
-            <a:ext cx="5712120" cy="4681366"/>
+            <a:off x="11291940" y="5783400"/>
+            <a:ext cx="5712120" cy="3920774"/>
           </a:xfrm>
           <a:prstGeom prst="rect">
             <a:avLst/>
@@ -4102,53 +4102,6 @@
           </a:bodyPr>
           <a:lstStyle/>
           <a:p>
-            <a:pPr algn="just">
-              <a:lnSpc>
-                <a:spcPts val="2999"/>
-              </a:lnSpc>
-            </a:pPr>
-            <a:r>
-              <a:rPr lang="pt-PT" sz="2400" b="0" strike="noStrike" spc="-1" dirty="0">
-                <a:solidFill>
-                  <a:srgbClr val="004B87"/>
-                </a:solidFill>
-                <a:latin typeface="Calibri"/>
-              </a:rPr>
-              <a:t>Write </a:t>
-            </a:r>
-            <a:r>
-              <a:rPr lang="pt-PT" sz="2400" b="0" strike="noStrike" spc="-1" dirty="0" err="1">
-                <a:solidFill>
-                  <a:srgbClr val="004B87"/>
-                </a:solidFill>
-                <a:latin typeface="Calibri"/>
-              </a:rPr>
-              <a:t>here</a:t>
-            </a:r>
-            <a:r>
-              <a:rPr lang="pt-PT" sz="2400" b="0" strike="noStrike" spc="-1" dirty="0">
-                <a:solidFill>
-                  <a:srgbClr val="004B87"/>
-                </a:solidFill>
-                <a:latin typeface="Calibri"/>
-              </a:rPr>
-              <a:t>...</a:t>
-            </a:r>
-            <a:endParaRPr lang="en-US" sz="2400" b="0" strike="noStrike" spc="-1" dirty="0">
-              <a:latin typeface="Arial"/>
-            </a:endParaRPr>
-          </a:p>
-          <a:p>
-            <a:pPr algn="just">
-              <a:lnSpc>
-                <a:spcPts val="2999"/>
-              </a:lnSpc>
-            </a:pPr>
-            <a:endParaRPr lang="en-US" sz="2400" b="0" strike="noStrike" spc="-1" dirty="0">
-              <a:latin typeface="Arial"/>
-            </a:endParaRPr>
-          </a:p>
-          <a:p>
             <a:pPr marL="457200" indent="-456840" algn="just">
               <a:lnSpc>
                 <a:spcPts val="2999"/>
@@ -4406,7 +4359,7 @@
         <p:spPr>
           <a:xfrm>
             <a:off x="14457600" y="19916280"/>
-            <a:ext cx="5646600" cy="629488"/>
+            <a:ext cx="5400705" cy="629488"/>
           </a:xfrm>
           <a:prstGeom prst="rect">
             <a:avLst/>
@@ -4446,7 +4399,25 @@
                 </a:solidFill>
                 <a:latin typeface="Calibri"/>
               </a:rPr>
-              <a:t>Documentação fornecida pelos docentes e trabalhadores da Ação Social</a:t>
+              <a:t>Documentação fornecida pelos docentes e </a:t>
+            </a:r>
+            <a:r>
+              <a:rPr lang="pt-PT" spc="-1" dirty="0">
+                <a:solidFill>
+                  <a:srgbClr val="004B87"/>
+                </a:solidFill>
+                <a:latin typeface="Calibri"/>
+              </a:rPr>
+              <a:t>Colaboradores</a:t>
+            </a:r>
+            <a:r>
+              <a:rPr lang="pt-PT" sz="1800" b="0" strike="noStrike" spc="-1" dirty="0">
+                <a:solidFill>
+                  <a:srgbClr val="004B87"/>
+                </a:solidFill>
+                <a:latin typeface="Calibri"/>
+              </a:rPr>
+              <a:t> da Ação Social</a:t>
             </a:r>
             <a:endParaRPr lang="en-US" sz="1800" b="0" strike="noStrike" spc="-1" dirty="0">
               <a:latin typeface="Arial"/>
@@ -4673,226 +4644,6 @@
               <a:t> Caldas)</a:t>
             </a:r>
             <a:endParaRPr lang="en-US" sz="1800" b="0" strike="noStrike" spc="-1" dirty="0">
-              <a:latin typeface="Arial"/>
-            </a:endParaRPr>
-          </a:p>
-        </p:txBody>
-      </p:sp>
-      <p:sp>
-        <p:nvSpPr>
-          <p:cNvPr id="67" name="CustomShape 20"/>
-          <p:cNvSpPr/>
-          <p:nvPr/>
-        </p:nvSpPr>
-        <p:spPr>
-          <a:xfrm>
-            <a:off x="14144760" y="5695560"/>
-            <a:ext cx="5616000" cy="3518280"/>
-          </a:xfrm>
-          <a:prstGeom prst="rect">
-            <a:avLst/>
-          </a:prstGeom>
-          <a:noFill/>
-          <a:ln>
-            <a:noFill/>
-          </a:ln>
-        </p:spPr>
-        <p:style>
-          <a:lnRef idx="0">
-            <a:scrgbClr r="0" g="0" b="0"/>
-          </a:lnRef>
-          <a:fillRef idx="0">
-            <a:scrgbClr r="0" g="0" b="0"/>
-          </a:fillRef>
-          <a:effectRef idx="0">
-            <a:scrgbClr r="0" g="0" b="0"/>
-          </a:effectRef>
-          <a:fontRef idx="minor"/>
-        </p:style>
-        <p:txBody>
-          <a:bodyPr lIns="90000" tIns="45000" rIns="90000" bIns="45000">
-            <a:spAutoFit/>
-          </a:bodyPr>
-          <a:lstStyle/>
-          <a:p>
-            <a:pPr algn="just">
-              <a:lnSpc>
-                <a:spcPts val="2999"/>
-              </a:lnSpc>
-            </a:pPr>
-            <a:r>
-              <a:rPr lang="pt-PT" sz="2400" b="0" strike="noStrike" spc="-1" dirty="0">
-                <a:solidFill>
-                  <a:srgbClr val="004B87"/>
-                </a:solidFill>
-                <a:latin typeface="Calibri"/>
-              </a:rPr>
-              <a:t>Write </a:t>
-            </a:r>
-            <a:r>
-              <a:rPr lang="pt-PT" sz="2400" b="0" strike="noStrike" spc="-1" dirty="0" err="1">
-                <a:solidFill>
-                  <a:srgbClr val="004B87"/>
-                </a:solidFill>
-                <a:latin typeface="Calibri"/>
-              </a:rPr>
-              <a:t>here</a:t>
-            </a:r>
-            <a:r>
-              <a:rPr lang="pt-PT" sz="2400" b="0" strike="noStrike" spc="-1" dirty="0">
-                <a:solidFill>
-                  <a:srgbClr val="004B87"/>
-                </a:solidFill>
-                <a:latin typeface="Calibri"/>
-              </a:rPr>
-              <a:t>...</a:t>
-            </a:r>
-            <a:endParaRPr lang="en-US" sz="2400" b="0" strike="noStrike" spc="-1" dirty="0">
-              <a:latin typeface="Arial"/>
-            </a:endParaRPr>
-          </a:p>
-          <a:p>
-            <a:pPr algn="just">
-              <a:lnSpc>
-                <a:spcPts val="2999"/>
-              </a:lnSpc>
-            </a:pPr>
-            <a:endParaRPr lang="en-US" sz="2400" b="0" strike="noStrike" spc="-1" dirty="0">
-              <a:latin typeface="Arial"/>
-            </a:endParaRPr>
-          </a:p>
-          <a:p>
-            <a:pPr marL="343080" indent="-342720" algn="just">
-              <a:lnSpc>
-                <a:spcPts val="2999"/>
-              </a:lnSpc>
-              <a:buSzPct val="100000"/>
-              <a:buBlip>
-                <a:blip r:embed="rId3"/>
-              </a:buBlip>
-            </a:pPr>
-            <a:r>
-              <a:rPr lang="pt-PT" sz="2400" b="0" strike="noStrike" spc="-1" dirty="0">
-                <a:solidFill>
-                  <a:srgbClr val="004B87"/>
-                </a:solidFill>
-                <a:latin typeface="Calibri"/>
-              </a:rPr>
-              <a:t>Item da lista 1</a:t>
-            </a:r>
-            <a:endParaRPr lang="en-US" sz="2400" b="0" strike="noStrike" spc="-1" dirty="0">
-              <a:latin typeface="Arial"/>
-            </a:endParaRPr>
-          </a:p>
-          <a:p>
-            <a:pPr marL="343080" indent="-342720" algn="just">
-              <a:lnSpc>
-                <a:spcPts val="2999"/>
-              </a:lnSpc>
-              <a:buSzPct val="100000"/>
-              <a:buBlip>
-                <a:blip r:embed="rId3"/>
-              </a:buBlip>
-            </a:pPr>
-            <a:r>
-              <a:rPr lang="pt-PT" sz="2400" b="0" strike="noStrike" spc="-1" dirty="0">
-                <a:solidFill>
-                  <a:srgbClr val="004B87"/>
-                </a:solidFill>
-                <a:latin typeface="Calibri"/>
-              </a:rPr>
-              <a:t>tem da lista 2</a:t>
-            </a:r>
-            <a:endParaRPr lang="en-US" sz="2400" b="0" strike="noStrike" spc="-1" dirty="0">
-              <a:latin typeface="Arial"/>
-            </a:endParaRPr>
-          </a:p>
-          <a:p>
-            <a:pPr marL="343080" indent="-342720" algn="just">
-              <a:lnSpc>
-                <a:spcPts val="2999"/>
-              </a:lnSpc>
-              <a:buSzPct val="100000"/>
-              <a:buBlip>
-                <a:blip r:embed="rId3"/>
-              </a:buBlip>
-            </a:pPr>
-            <a:r>
-              <a:rPr lang="pt-PT" sz="2400" b="0" strike="noStrike" spc="-1" dirty="0">
-                <a:solidFill>
-                  <a:srgbClr val="004B87"/>
-                </a:solidFill>
-                <a:latin typeface="Calibri"/>
-              </a:rPr>
-              <a:t>Item da lista 3</a:t>
-            </a:r>
-            <a:endParaRPr lang="en-US" sz="2400" b="0" strike="noStrike" spc="-1" dirty="0">
-              <a:latin typeface="Arial"/>
-            </a:endParaRPr>
-          </a:p>
-          <a:p>
-            <a:pPr marL="343080" indent="-342720" algn="just">
-              <a:lnSpc>
-                <a:spcPts val="2999"/>
-              </a:lnSpc>
-              <a:buSzPct val="100000"/>
-              <a:buBlip>
-                <a:blip r:embed="rId3"/>
-              </a:buBlip>
-            </a:pPr>
-            <a:r>
-              <a:rPr lang="pt-PT" sz="2400" b="0" strike="noStrike" spc="-1" dirty="0">
-                <a:solidFill>
-                  <a:srgbClr val="004B87"/>
-                </a:solidFill>
-                <a:latin typeface="Calibri"/>
-              </a:rPr>
-              <a:t>Item da lista 4</a:t>
-            </a:r>
-            <a:endParaRPr lang="en-US" sz="2400" b="0" strike="noStrike" spc="-1" dirty="0">
-              <a:latin typeface="Arial"/>
-            </a:endParaRPr>
-          </a:p>
-          <a:p>
-            <a:pPr marL="343080" indent="-342720" algn="just">
-              <a:lnSpc>
-                <a:spcPts val="2999"/>
-              </a:lnSpc>
-              <a:buSzPct val="100000"/>
-              <a:buBlip>
-                <a:blip r:embed="rId3"/>
-              </a:buBlip>
-            </a:pPr>
-            <a:r>
-              <a:rPr lang="pt-PT" sz="2400" b="0" strike="noStrike" spc="-1" dirty="0">
-                <a:solidFill>
-                  <a:srgbClr val="004B87"/>
-                </a:solidFill>
-                <a:latin typeface="Calibri"/>
-              </a:rPr>
-              <a:t>Item da lista 5</a:t>
-            </a:r>
-            <a:endParaRPr lang="en-US" sz="2400" b="0" strike="noStrike" spc="-1" dirty="0">
-              <a:latin typeface="Arial"/>
-            </a:endParaRPr>
-          </a:p>
-          <a:p>
-            <a:pPr algn="just">
-              <a:lnSpc>
-                <a:spcPts val="2999"/>
-              </a:lnSpc>
-            </a:pPr>
-            <a:endParaRPr lang="en-US" sz="2400" b="0" strike="noStrike" spc="-1" dirty="0">
-              <a:latin typeface="Arial"/>
-            </a:endParaRPr>
-          </a:p>
-          <a:p>
-            <a:pPr algn="just">
-              <a:lnSpc>
-                <a:spcPts val="2999"/>
-              </a:lnSpc>
-            </a:pPr>
-            <a:endParaRPr lang="en-US" sz="2400" b="0" strike="noStrike" spc="-1" dirty="0">
               <a:latin typeface="Arial"/>
             </a:endParaRPr>
           </a:p>

</xml_diff>

<commit_message>
Revert "Update docs and improve basket preparation button"
This reverts commit d395a1e16afd4501692705efcd11ed6571bc1fe7.
</commit_message>
<xml_diff>
--- a/docs/poster.pptx
+++ b/docs/poster.pptx
@@ -3428,7 +3428,7 @@
         </p:blipFill>
         <p:spPr>
           <a:xfrm>
-            <a:off x="11434500" y="5204160"/>
+            <a:off x="8060760" y="5116320"/>
             <a:ext cx="304560" cy="367920"/>
           </a:xfrm>
           <a:prstGeom prst="rect">
@@ -3786,7 +3786,7 @@
         </p:nvSpPr>
         <p:spPr>
           <a:xfrm>
-            <a:off x="11781900" y="5116320"/>
+            <a:off x="8408160" y="5028480"/>
             <a:ext cx="4725720" cy="639360"/>
           </a:xfrm>
           <a:prstGeom prst="rect">
@@ -3825,7 +3825,7 @@
               </a:lnSpc>
             </a:pPr>
             <a:r>
-              <a:rPr lang="pt-PT" sz="3600" b="1" strike="noStrike" spc="-1" dirty="0">
+              <a:rPr lang="pt-PT" sz="3600" b="1" strike="noStrike" spc="-1">
                 <a:solidFill>
                   <a:srgbClr val="004B87"/>
                 </a:solidFill>
@@ -3833,7 +3833,7 @@
               </a:rPr>
               <a:t>OBJECTIVES</a:t>
             </a:r>
-            <a:endParaRPr lang="en-US" sz="3600" b="0" strike="noStrike" spc="-1" dirty="0">
+            <a:endParaRPr lang="en-US" sz="3600" b="0" strike="noStrike" spc="-1">
               <a:latin typeface="Arial"/>
             </a:endParaRPr>
           </a:p>
@@ -4073,8 +4073,8 @@
         </p:nvSpPr>
         <p:spPr>
           <a:xfrm>
-            <a:off x="11291940" y="5783400"/>
-            <a:ext cx="5712120" cy="3920774"/>
+            <a:off x="7918200" y="5695560"/>
+            <a:ext cx="5712120" cy="4681366"/>
           </a:xfrm>
           <a:prstGeom prst="rect">
             <a:avLst/>
@@ -4102,6 +4102,53 @@
           </a:bodyPr>
           <a:lstStyle/>
           <a:p>
+            <a:pPr algn="just">
+              <a:lnSpc>
+                <a:spcPts val="2999"/>
+              </a:lnSpc>
+            </a:pPr>
+            <a:r>
+              <a:rPr lang="pt-PT" sz="2400" b="0" strike="noStrike" spc="-1" dirty="0">
+                <a:solidFill>
+                  <a:srgbClr val="004B87"/>
+                </a:solidFill>
+                <a:latin typeface="Calibri"/>
+              </a:rPr>
+              <a:t>Write </a:t>
+            </a:r>
+            <a:r>
+              <a:rPr lang="pt-PT" sz="2400" b="0" strike="noStrike" spc="-1" dirty="0" err="1">
+                <a:solidFill>
+                  <a:srgbClr val="004B87"/>
+                </a:solidFill>
+                <a:latin typeface="Calibri"/>
+              </a:rPr>
+              <a:t>here</a:t>
+            </a:r>
+            <a:r>
+              <a:rPr lang="pt-PT" sz="2400" b="0" strike="noStrike" spc="-1" dirty="0">
+                <a:solidFill>
+                  <a:srgbClr val="004B87"/>
+                </a:solidFill>
+                <a:latin typeface="Calibri"/>
+              </a:rPr>
+              <a:t>...</a:t>
+            </a:r>
+            <a:endParaRPr lang="en-US" sz="2400" b="0" strike="noStrike" spc="-1" dirty="0">
+              <a:latin typeface="Arial"/>
+            </a:endParaRPr>
+          </a:p>
+          <a:p>
+            <a:pPr algn="just">
+              <a:lnSpc>
+                <a:spcPts val="2999"/>
+              </a:lnSpc>
+            </a:pPr>
+            <a:endParaRPr lang="en-US" sz="2400" b="0" strike="noStrike" spc="-1" dirty="0">
+              <a:latin typeface="Arial"/>
+            </a:endParaRPr>
+          </a:p>
+          <a:p>
             <a:pPr marL="457200" indent="-456840" algn="just">
               <a:lnSpc>
                 <a:spcPts val="2999"/>
@@ -4359,7 +4406,7 @@
         <p:spPr>
           <a:xfrm>
             <a:off x="14457600" y="19916280"/>
-            <a:ext cx="5400705" cy="629488"/>
+            <a:ext cx="5646600" cy="629488"/>
           </a:xfrm>
           <a:prstGeom prst="rect">
             <a:avLst/>
@@ -4399,25 +4446,7 @@
                 </a:solidFill>
                 <a:latin typeface="Calibri"/>
               </a:rPr>
-              <a:t>Documentação fornecida pelos docentes e </a:t>
-            </a:r>
-            <a:r>
-              <a:rPr lang="pt-PT" spc="-1" dirty="0">
-                <a:solidFill>
-                  <a:srgbClr val="004B87"/>
-                </a:solidFill>
-                <a:latin typeface="Calibri"/>
-              </a:rPr>
-              <a:t>Colaboradores</a:t>
-            </a:r>
-            <a:r>
-              <a:rPr lang="pt-PT" sz="1800" b="0" strike="noStrike" spc="-1" dirty="0">
-                <a:solidFill>
-                  <a:srgbClr val="004B87"/>
-                </a:solidFill>
-                <a:latin typeface="Calibri"/>
-              </a:rPr>
-              <a:t> da Ação Social</a:t>
+              <a:t>Documentação fornecida pelos docentes e trabalhadores da Ação Social</a:t>
             </a:r>
             <a:endParaRPr lang="en-US" sz="1800" b="0" strike="noStrike" spc="-1" dirty="0">
               <a:latin typeface="Arial"/>
@@ -4644,6 +4673,226 @@
               <a:t> Caldas)</a:t>
             </a:r>
             <a:endParaRPr lang="en-US" sz="1800" b="0" strike="noStrike" spc="-1" dirty="0">
+              <a:latin typeface="Arial"/>
+            </a:endParaRPr>
+          </a:p>
+        </p:txBody>
+      </p:sp>
+      <p:sp>
+        <p:nvSpPr>
+          <p:cNvPr id="67" name="CustomShape 20"/>
+          <p:cNvSpPr/>
+          <p:nvPr/>
+        </p:nvSpPr>
+        <p:spPr>
+          <a:xfrm>
+            <a:off x="14144760" y="5695560"/>
+            <a:ext cx="5616000" cy="3518280"/>
+          </a:xfrm>
+          <a:prstGeom prst="rect">
+            <a:avLst/>
+          </a:prstGeom>
+          <a:noFill/>
+          <a:ln>
+            <a:noFill/>
+          </a:ln>
+        </p:spPr>
+        <p:style>
+          <a:lnRef idx="0">
+            <a:scrgbClr r="0" g="0" b="0"/>
+          </a:lnRef>
+          <a:fillRef idx="0">
+            <a:scrgbClr r="0" g="0" b="0"/>
+          </a:fillRef>
+          <a:effectRef idx="0">
+            <a:scrgbClr r="0" g="0" b="0"/>
+          </a:effectRef>
+          <a:fontRef idx="minor"/>
+        </p:style>
+        <p:txBody>
+          <a:bodyPr lIns="90000" tIns="45000" rIns="90000" bIns="45000">
+            <a:spAutoFit/>
+          </a:bodyPr>
+          <a:lstStyle/>
+          <a:p>
+            <a:pPr algn="just">
+              <a:lnSpc>
+                <a:spcPts val="2999"/>
+              </a:lnSpc>
+            </a:pPr>
+            <a:r>
+              <a:rPr lang="pt-PT" sz="2400" b="0" strike="noStrike" spc="-1" dirty="0">
+                <a:solidFill>
+                  <a:srgbClr val="004B87"/>
+                </a:solidFill>
+                <a:latin typeface="Calibri"/>
+              </a:rPr>
+              <a:t>Write </a:t>
+            </a:r>
+            <a:r>
+              <a:rPr lang="pt-PT" sz="2400" b="0" strike="noStrike" spc="-1" dirty="0" err="1">
+                <a:solidFill>
+                  <a:srgbClr val="004B87"/>
+                </a:solidFill>
+                <a:latin typeface="Calibri"/>
+              </a:rPr>
+              <a:t>here</a:t>
+            </a:r>
+            <a:r>
+              <a:rPr lang="pt-PT" sz="2400" b="0" strike="noStrike" spc="-1" dirty="0">
+                <a:solidFill>
+                  <a:srgbClr val="004B87"/>
+                </a:solidFill>
+                <a:latin typeface="Calibri"/>
+              </a:rPr>
+              <a:t>...</a:t>
+            </a:r>
+            <a:endParaRPr lang="en-US" sz="2400" b="0" strike="noStrike" spc="-1" dirty="0">
+              <a:latin typeface="Arial"/>
+            </a:endParaRPr>
+          </a:p>
+          <a:p>
+            <a:pPr algn="just">
+              <a:lnSpc>
+                <a:spcPts val="2999"/>
+              </a:lnSpc>
+            </a:pPr>
+            <a:endParaRPr lang="en-US" sz="2400" b="0" strike="noStrike" spc="-1" dirty="0">
+              <a:latin typeface="Arial"/>
+            </a:endParaRPr>
+          </a:p>
+          <a:p>
+            <a:pPr marL="343080" indent="-342720" algn="just">
+              <a:lnSpc>
+                <a:spcPts val="2999"/>
+              </a:lnSpc>
+              <a:buSzPct val="100000"/>
+              <a:buBlip>
+                <a:blip r:embed="rId3"/>
+              </a:buBlip>
+            </a:pPr>
+            <a:r>
+              <a:rPr lang="pt-PT" sz="2400" b="0" strike="noStrike" spc="-1" dirty="0">
+                <a:solidFill>
+                  <a:srgbClr val="004B87"/>
+                </a:solidFill>
+                <a:latin typeface="Calibri"/>
+              </a:rPr>
+              <a:t>Item da lista 1</a:t>
+            </a:r>
+            <a:endParaRPr lang="en-US" sz="2400" b="0" strike="noStrike" spc="-1" dirty="0">
+              <a:latin typeface="Arial"/>
+            </a:endParaRPr>
+          </a:p>
+          <a:p>
+            <a:pPr marL="343080" indent="-342720" algn="just">
+              <a:lnSpc>
+                <a:spcPts val="2999"/>
+              </a:lnSpc>
+              <a:buSzPct val="100000"/>
+              <a:buBlip>
+                <a:blip r:embed="rId3"/>
+              </a:buBlip>
+            </a:pPr>
+            <a:r>
+              <a:rPr lang="pt-PT" sz="2400" b="0" strike="noStrike" spc="-1" dirty="0">
+                <a:solidFill>
+                  <a:srgbClr val="004B87"/>
+                </a:solidFill>
+                <a:latin typeface="Calibri"/>
+              </a:rPr>
+              <a:t>tem da lista 2</a:t>
+            </a:r>
+            <a:endParaRPr lang="en-US" sz="2400" b="0" strike="noStrike" spc="-1" dirty="0">
+              <a:latin typeface="Arial"/>
+            </a:endParaRPr>
+          </a:p>
+          <a:p>
+            <a:pPr marL="343080" indent="-342720" algn="just">
+              <a:lnSpc>
+                <a:spcPts val="2999"/>
+              </a:lnSpc>
+              <a:buSzPct val="100000"/>
+              <a:buBlip>
+                <a:blip r:embed="rId3"/>
+              </a:buBlip>
+            </a:pPr>
+            <a:r>
+              <a:rPr lang="pt-PT" sz="2400" b="0" strike="noStrike" spc="-1" dirty="0">
+                <a:solidFill>
+                  <a:srgbClr val="004B87"/>
+                </a:solidFill>
+                <a:latin typeface="Calibri"/>
+              </a:rPr>
+              <a:t>Item da lista 3</a:t>
+            </a:r>
+            <a:endParaRPr lang="en-US" sz="2400" b="0" strike="noStrike" spc="-1" dirty="0">
+              <a:latin typeface="Arial"/>
+            </a:endParaRPr>
+          </a:p>
+          <a:p>
+            <a:pPr marL="343080" indent="-342720" algn="just">
+              <a:lnSpc>
+                <a:spcPts val="2999"/>
+              </a:lnSpc>
+              <a:buSzPct val="100000"/>
+              <a:buBlip>
+                <a:blip r:embed="rId3"/>
+              </a:buBlip>
+            </a:pPr>
+            <a:r>
+              <a:rPr lang="pt-PT" sz="2400" b="0" strike="noStrike" spc="-1" dirty="0">
+                <a:solidFill>
+                  <a:srgbClr val="004B87"/>
+                </a:solidFill>
+                <a:latin typeface="Calibri"/>
+              </a:rPr>
+              <a:t>Item da lista 4</a:t>
+            </a:r>
+            <a:endParaRPr lang="en-US" sz="2400" b="0" strike="noStrike" spc="-1" dirty="0">
+              <a:latin typeface="Arial"/>
+            </a:endParaRPr>
+          </a:p>
+          <a:p>
+            <a:pPr marL="343080" indent="-342720" algn="just">
+              <a:lnSpc>
+                <a:spcPts val="2999"/>
+              </a:lnSpc>
+              <a:buSzPct val="100000"/>
+              <a:buBlip>
+                <a:blip r:embed="rId3"/>
+              </a:buBlip>
+            </a:pPr>
+            <a:r>
+              <a:rPr lang="pt-PT" sz="2400" b="0" strike="noStrike" spc="-1" dirty="0">
+                <a:solidFill>
+                  <a:srgbClr val="004B87"/>
+                </a:solidFill>
+                <a:latin typeface="Calibri"/>
+              </a:rPr>
+              <a:t>Item da lista 5</a:t>
+            </a:r>
+            <a:endParaRPr lang="en-US" sz="2400" b="0" strike="noStrike" spc="-1" dirty="0">
+              <a:latin typeface="Arial"/>
+            </a:endParaRPr>
+          </a:p>
+          <a:p>
+            <a:pPr algn="just">
+              <a:lnSpc>
+                <a:spcPts val="2999"/>
+              </a:lnSpc>
+            </a:pPr>
+            <a:endParaRPr lang="en-US" sz="2400" b="0" strike="noStrike" spc="-1" dirty="0">
+              <a:latin typeface="Arial"/>
+            </a:endParaRPr>
+          </a:p>
+          <a:p>
+            <a:pPr algn="just">
+              <a:lnSpc>
+                <a:spcPts val="2999"/>
+              </a:lnSpc>
+            </a:pPr>
+            <a:endParaRPr lang="en-US" sz="2400" b="0" strike="noStrike" spc="-1" dirty="0">
               <a:latin typeface="Arial"/>
             </a:endParaRPr>
           </a:p>

</xml_diff>